<commit_message>
Day 1: the folder as it stands, and HTML joins the formats
An nbconvert export dropped beside a notebook now gets its own button, so the
14:30 laboratory can be read in a browser without Colab and without installing
anything. HTML is recognised but never scaffolded: a placeholder is a request,
and an export is expected of nobody — it renders a notebook that already has
its own button and its own Colab badge.

Also from docs/downloads/Day1, as supplied: the 14:00 infrastructure deck
re-exported at 63 slides, with its French PDF; the AI family tree French deck
re-saved; and the RAG notebook's active DOCUMENTS line back to "example"
instead of a personal Drive link.
</commit_message>
<xml_diff>
--- a/docs/downloads/Day1/1005_ai-family-tree_FR.pptx
+++ b/docs/downloads/Day1/1005_ai-family-tree_FR.pptx
@@ -32217,74 +32217,6 @@
       </p:sp>
       <p:sp>
         <p:nvSpPr>
-          <p:cNvPr id="14" name="Shape 12"/>
-          <p:cNvSpPr/>
-          <p:nvPr/>
-        </p:nvSpPr>
-        <p:spPr>
-          <a:xfrm>
-            <a:off x="2286000" y="1600200"/>
-            <a:ext cx="594360" cy="219456"/>
-          </a:xfrm>
-          <a:prstGeom prst="roundRect">
-            <a:avLst>
-              <a:gd name="adj" fmla="val 50000"/>
-            </a:avLst>
-          </a:prstGeom>
-          <a:solidFill>
-            <a:srgbClr val="00A86A">
-              <a:alpha val="15000"/>
-            </a:srgbClr>
-          </a:solidFill>
-          <a:ln w="9525">
-            <a:solidFill>
-              <a:srgbClr val="00A86A"/>
-            </a:solidFill>
-            <a:prstDash val="solid"/>
-          </a:ln>
-        </p:spPr>
-      </p:sp>
-      <p:sp>
-        <p:nvSpPr>
-          <p:cNvPr id="15" name="Text 13"/>
-          <p:cNvSpPr txBox="1"/>
-          <p:nvPr/>
-        </p:nvSpPr>
-        <p:spPr>
-          <a:xfrm>
-            <a:off x="2286000" y="1600200"/>
-            <a:ext cx="594360" cy="219456"/>
-          </a:xfrm>
-          <a:prstGeom prst="rect">
-            <a:avLst/>
-          </a:prstGeom>
-          <a:noFill/>
-          <a:ln/>
-        </p:spPr>
-        <p:txBody>
-          <a:bodyPr wrap="square" lIns="0" tIns="0" rIns="0" bIns="0" rtlCol="0" anchor="ctr"/>
-          <a:lstStyle/>
-          <a:p>
-            <a:pPr marL="0" indent="0" algn="ctr">
-              <a:buNone/>
-            </a:pPr>
-            <a:r>
-              <a:rPr lang="en-US" sz="900" b="1" dirty="0">
-                <a:solidFill>
-                  <a:srgbClr val="00A86A"/>
-                </a:solidFill>
-                <a:latin typeface="Calibri" pitchFamily="34" charset="0"/>
-                <a:ea typeface="Calibri" pitchFamily="34" charset="-122"/>
-                <a:cs typeface="Calibri" pitchFamily="34" charset="-120"/>
-              </a:rPr>
-              <a:t>2 min</a:t>
-            </a:r>
-            <a:endParaRPr lang="en-US" sz="900" dirty="0"/>
-          </a:p>
-        </p:txBody>
-      </p:sp>
-      <p:sp>
-        <p:nvSpPr>
           <p:cNvPr id="16" name="Shape 14"/>
           <p:cNvSpPr/>
           <p:nvPr/>
@@ -32429,74 +32361,6 @@
       </p:sp>
       <p:sp>
         <p:nvSpPr>
-          <p:cNvPr id="20" name="Shape 18"/>
-          <p:cNvSpPr/>
-          <p:nvPr/>
-        </p:nvSpPr>
-        <p:spPr>
-          <a:xfrm>
-            <a:off x="5074920" y="1600200"/>
-            <a:ext cx="594360" cy="219456"/>
-          </a:xfrm>
-          <a:prstGeom prst="roundRect">
-            <a:avLst>
-              <a:gd name="adj" fmla="val 50000"/>
-            </a:avLst>
-          </a:prstGeom>
-          <a:solidFill>
-            <a:srgbClr val="00704A">
-              <a:alpha val="15000"/>
-            </a:srgbClr>
-          </a:solidFill>
-          <a:ln w="9525">
-            <a:solidFill>
-              <a:srgbClr val="00704A"/>
-            </a:solidFill>
-            <a:prstDash val="solid"/>
-          </a:ln>
-        </p:spPr>
-      </p:sp>
-      <p:sp>
-        <p:nvSpPr>
-          <p:cNvPr id="21" name="Text 19"/>
-          <p:cNvSpPr txBox="1"/>
-          <p:nvPr/>
-        </p:nvSpPr>
-        <p:spPr>
-          <a:xfrm>
-            <a:off x="5074920" y="1600200"/>
-            <a:ext cx="594360" cy="219456"/>
-          </a:xfrm>
-          <a:prstGeom prst="rect">
-            <a:avLst/>
-          </a:prstGeom>
-          <a:noFill/>
-          <a:ln/>
-        </p:spPr>
-        <p:txBody>
-          <a:bodyPr wrap="square" lIns="0" tIns="0" rIns="0" bIns="0" rtlCol="0" anchor="ctr"/>
-          <a:lstStyle/>
-          <a:p>
-            <a:pPr marL="0" indent="0" algn="ctr">
-              <a:buNone/>
-            </a:pPr>
-            <a:r>
-              <a:rPr lang="en-US" sz="900" b="1" dirty="0">
-                <a:solidFill>
-                  <a:srgbClr val="00704A"/>
-                </a:solidFill>
-                <a:latin typeface="Calibri" pitchFamily="34" charset="0"/>
-                <a:ea typeface="Calibri" pitchFamily="34" charset="-122"/>
-                <a:cs typeface="Calibri" pitchFamily="34" charset="-120"/>
-              </a:rPr>
-              <a:t>6 min</a:t>
-            </a:r>
-            <a:endParaRPr lang="en-US" sz="900" dirty="0"/>
-          </a:p>
-        </p:txBody>
-      </p:sp>
-      <p:sp>
-        <p:nvSpPr>
           <p:cNvPr id="22" name="Shape 20"/>
           <p:cNvSpPr/>
           <p:nvPr/>
@@ -32641,74 +32505,6 @@
       </p:sp>
       <p:sp>
         <p:nvSpPr>
-          <p:cNvPr id="26" name="Shape 24"/>
-          <p:cNvSpPr/>
-          <p:nvPr/>
-        </p:nvSpPr>
-        <p:spPr>
-          <a:xfrm>
-            <a:off x="7863840" y="1600200"/>
-            <a:ext cx="594360" cy="219456"/>
-          </a:xfrm>
-          <a:prstGeom prst="roundRect">
-            <a:avLst>
-              <a:gd name="adj" fmla="val 50000"/>
-            </a:avLst>
-          </a:prstGeom>
-          <a:solidFill>
-            <a:srgbClr val="0E7C86">
-              <a:alpha val="15000"/>
-            </a:srgbClr>
-          </a:solidFill>
-          <a:ln w="9525">
-            <a:solidFill>
-              <a:srgbClr val="0E7C86"/>
-            </a:solidFill>
-            <a:prstDash val="solid"/>
-          </a:ln>
-        </p:spPr>
-      </p:sp>
-      <p:sp>
-        <p:nvSpPr>
-          <p:cNvPr id="27" name="Text 25"/>
-          <p:cNvSpPr txBox="1"/>
-          <p:nvPr/>
-        </p:nvSpPr>
-        <p:spPr>
-          <a:xfrm>
-            <a:off x="7863840" y="1600200"/>
-            <a:ext cx="594360" cy="219456"/>
-          </a:xfrm>
-          <a:prstGeom prst="rect">
-            <a:avLst/>
-          </a:prstGeom>
-          <a:noFill/>
-          <a:ln/>
-        </p:spPr>
-        <p:txBody>
-          <a:bodyPr wrap="square" lIns="0" tIns="0" rIns="0" bIns="0" rtlCol="0" anchor="ctr"/>
-          <a:lstStyle/>
-          <a:p>
-            <a:pPr marL="0" indent="0" algn="ctr">
-              <a:buNone/>
-            </a:pPr>
-            <a:r>
-              <a:rPr lang="en-US" sz="900" b="1" dirty="0">
-                <a:solidFill>
-                  <a:srgbClr val="0E7C86"/>
-                </a:solidFill>
-                <a:latin typeface="Calibri" pitchFamily="34" charset="0"/>
-                <a:ea typeface="Calibri" pitchFamily="34" charset="-122"/>
-                <a:cs typeface="Calibri" pitchFamily="34" charset="-120"/>
-              </a:rPr>
-              <a:t>6 min</a:t>
-            </a:r>
-            <a:endParaRPr lang="en-US" sz="900" dirty="0"/>
-          </a:p>
-        </p:txBody>
-      </p:sp>
-      <p:sp>
-        <p:nvSpPr>
           <p:cNvPr id="28" name="Shape 26"/>
           <p:cNvSpPr/>
           <p:nvPr/>
@@ -32853,74 +32649,6 @@
       </p:sp>
       <p:sp>
         <p:nvSpPr>
-          <p:cNvPr id="32" name="Shape 30"/>
-          <p:cNvSpPr/>
-          <p:nvPr/>
-        </p:nvSpPr>
-        <p:spPr>
-          <a:xfrm>
-            <a:off x="2286000" y="3200400"/>
-            <a:ext cx="594360" cy="219456"/>
-          </a:xfrm>
-          <a:prstGeom prst="roundRect">
-            <a:avLst>
-              <a:gd name="adj" fmla="val 50000"/>
-            </a:avLst>
-          </a:prstGeom>
-          <a:solidFill>
-            <a:srgbClr val="D49A00">
-              <a:alpha val="15000"/>
-            </a:srgbClr>
-          </a:solidFill>
-          <a:ln w="9525">
-            <a:solidFill>
-              <a:srgbClr val="D49A00"/>
-            </a:solidFill>
-            <a:prstDash val="solid"/>
-          </a:ln>
-        </p:spPr>
-      </p:sp>
-      <p:sp>
-        <p:nvSpPr>
-          <p:cNvPr id="33" name="Text 31"/>
-          <p:cNvSpPr txBox="1"/>
-          <p:nvPr/>
-        </p:nvSpPr>
-        <p:spPr>
-          <a:xfrm>
-            <a:off x="2286000" y="3200400"/>
-            <a:ext cx="594360" cy="219456"/>
-          </a:xfrm>
-          <a:prstGeom prst="rect">
-            <a:avLst/>
-          </a:prstGeom>
-          <a:noFill/>
-          <a:ln/>
-        </p:spPr>
-        <p:txBody>
-          <a:bodyPr wrap="square" lIns="0" tIns="0" rIns="0" bIns="0" rtlCol="0" anchor="ctr"/>
-          <a:lstStyle/>
-          <a:p>
-            <a:pPr marL="0" indent="0" algn="ctr">
-              <a:buNone/>
-            </a:pPr>
-            <a:r>
-              <a:rPr lang="en-US" sz="900" b="1" dirty="0">
-                <a:solidFill>
-                  <a:srgbClr val="D49A00"/>
-                </a:solidFill>
-                <a:latin typeface="Calibri" pitchFamily="34" charset="0"/>
-                <a:ea typeface="Calibri" pitchFamily="34" charset="-122"/>
-                <a:cs typeface="Calibri" pitchFamily="34" charset="-120"/>
-              </a:rPr>
-              <a:t>6 min</a:t>
-            </a:r>
-            <a:endParaRPr lang="en-US" sz="900" dirty="0"/>
-          </a:p>
-        </p:txBody>
-      </p:sp>
-      <p:sp>
-        <p:nvSpPr>
           <p:cNvPr id="34" name="Shape 32"/>
           <p:cNvSpPr/>
           <p:nvPr/>
@@ -33065,74 +32793,6 @@
       </p:sp>
       <p:sp>
         <p:nvSpPr>
-          <p:cNvPr id="38" name="Shape 36"/>
-          <p:cNvSpPr/>
-          <p:nvPr/>
-        </p:nvSpPr>
-        <p:spPr>
-          <a:xfrm>
-            <a:off x="5074920" y="3200400"/>
-            <a:ext cx="594360" cy="219456"/>
-          </a:xfrm>
-          <a:prstGeom prst="roundRect">
-            <a:avLst>
-              <a:gd name="adj" fmla="val 50000"/>
-            </a:avLst>
-          </a:prstGeom>
-          <a:solidFill>
-            <a:srgbClr val="C4621D">
-              <a:alpha val="15000"/>
-            </a:srgbClr>
-          </a:solidFill>
-          <a:ln w="9525">
-            <a:solidFill>
-              <a:srgbClr val="C4621D"/>
-            </a:solidFill>
-            <a:prstDash val="solid"/>
-          </a:ln>
-        </p:spPr>
-      </p:sp>
-      <p:sp>
-        <p:nvSpPr>
-          <p:cNvPr id="39" name="Text 37"/>
-          <p:cNvSpPr txBox="1"/>
-          <p:nvPr/>
-        </p:nvSpPr>
-        <p:spPr>
-          <a:xfrm>
-            <a:off x="5074920" y="3200400"/>
-            <a:ext cx="594360" cy="219456"/>
-          </a:xfrm>
-          <a:prstGeom prst="rect">
-            <a:avLst/>
-          </a:prstGeom>
-          <a:noFill/>
-          <a:ln/>
-        </p:spPr>
-        <p:txBody>
-          <a:bodyPr wrap="square" lIns="0" tIns="0" rIns="0" bIns="0" rtlCol="0" anchor="ctr"/>
-          <a:lstStyle/>
-          <a:p>
-            <a:pPr marL="0" indent="0" algn="ctr">
-              <a:buNone/>
-            </a:pPr>
-            <a:r>
-              <a:rPr lang="en-US" sz="900" b="1" dirty="0">
-                <a:solidFill>
-                  <a:srgbClr val="C4621D"/>
-                </a:solidFill>
-                <a:latin typeface="Calibri" pitchFamily="34" charset="0"/>
-                <a:ea typeface="Calibri" pitchFamily="34" charset="-122"/>
-                <a:cs typeface="Calibri" pitchFamily="34" charset="-120"/>
-              </a:rPr>
-              <a:t>5 min</a:t>
-            </a:r>
-            <a:endParaRPr lang="en-US" sz="900" dirty="0"/>
-          </a:p>
-        </p:txBody>
-      </p:sp>
-      <p:sp>
-        <p:nvSpPr>
           <p:cNvPr id="40" name="Shape 38"/>
           <p:cNvSpPr/>
           <p:nvPr/>
@@ -33272,74 +32932,6 @@
               <a:t>AI Ready, peut / ne peut pas, ligne rouge</a:t>
             </a:r>
             <a:endParaRPr lang="en-US" sz="1000" dirty="0"/>
-          </a:p>
-        </p:txBody>
-      </p:sp>
-      <p:sp>
-        <p:nvSpPr>
-          <p:cNvPr id="44" name="Shape 42"/>
-          <p:cNvSpPr/>
-          <p:nvPr/>
-        </p:nvSpPr>
-        <p:spPr>
-          <a:xfrm>
-            <a:off x="7863840" y="3200400"/>
-            <a:ext cx="594360" cy="219456"/>
-          </a:xfrm>
-          <a:prstGeom prst="roundRect">
-            <a:avLst>
-              <a:gd name="adj" fmla="val 50000"/>
-            </a:avLst>
-          </a:prstGeom>
-          <a:solidFill>
-            <a:srgbClr val="B83B2E">
-              <a:alpha val="15000"/>
-            </a:srgbClr>
-          </a:solidFill>
-          <a:ln w="9525">
-            <a:solidFill>
-              <a:srgbClr val="B83B2E"/>
-            </a:solidFill>
-            <a:prstDash val="solid"/>
-          </a:ln>
-        </p:spPr>
-      </p:sp>
-      <p:sp>
-        <p:nvSpPr>
-          <p:cNvPr id="45" name="Text 43"/>
-          <p:cNvSpPr txBox="1"/>
-          <p:nvPr/>
-        </p:nvSpPr>
-        <p:spPr>
-          <a:xfrm>
-            <a:off x="7863840" y="3200400"/>
-            <a:ext cx="594360" cy="219456"/>
-          </a:xfrm>
-          <a:prstGeom prst="rect">
-            <a:avLst/>
-          </a:prstGeom>
-          <a:noFill/>
-          <a:ln/>
-        </p:spPr>
-        <p:txBody>
-          <a:bodyPr wrap="square" lIns="0" tIns="0" rIns="0" bIns="0" rtlCol="0" anchor="ctr"/>
-          <a:lstStyle/>
-          <a:p>
-            <a:pPr marL="0" indent="0" algn="ctr">
-              <a:buNone/>
-            </a:pPr>
-            <a:r>
-              <a:rPr lang="en-US" sz="900" b="1" dirty="0">
-                <a:solidFill>
-                  <a:srgbClr val="B83B2E"/>
-                </a:solidFill>
-                <a:latin typeface="Calibri" pitchFamily="34" charset="0"/>
-                <a:ea typeface="Calibri" pitchFamily="34" charset="-122"/>
-                <a:cs typeface="Calibri" pitchFamily="34" charset="-120"/>
-              </a:rPr>
-              <a:t>5 min</a:t>
-            </a:r>
-            <a:endParaRPr lang="en-US" sz="900" dirty="0"/>
           </a:p>
         </p:txBody>
       </p:sp>

</xml_diff>